<commit_message>
deck: fix PowerPoint repair prompt (raw newline in text run on slide 9)
Slide 9 cascade customer boxes used a literal '\n' inside a text run, which produced a newline inside <a:t> that PowerPoint flagged for repair (LibreOffice tolerated it). Use breakLine:true on the first run instead. Validated: 0 XML parse errors, 0 raw newlines in <a:t>, 0 broken relationships / content-type issues across all 110 parts.

Co-authored-by: Copilot <223556219+Copilot@users.noreply.github.com>
</commit_message>
<xml_diff>
--- a/docs/FY27 EMEA EPS - Fabric Apps Motion - Micro Hack.pptx
+++ b/docs/FY27 EMEA EPS - Fabric Apps Motion - Micro Hack.pptx
@@ -19863,9 +19863,11 @@
                 <a:ea typeface="Calibri" pitchFamily="34" charset="-122"/>
                 <a:cs typeface="Calibri" pitchFamily="34" charset="-120"/>
               </a:rPr>
-              <a:t>Customer 1
-</a:t>
-            </a:r>
+              <a:t>Customer 1</a:t>
+            </a:r>
+            <a:endParaRPr lang="en-US" sz="1100" dirty="0"/>
+          </a:p>
+          <a:p>
             <a:pPr algn="ctr" indent="0" marL="0">
               <a:buNone/>
             </a:pPr>
@@ -19992,9 +19994,11 @@
                 <a:ea typeface="Calibri" pitchFamily="34" charset="-122"/>
                 <a:cs typeface="Calibri" pitchFamily="34" charset="-120"/>
               </a:rPr>
-              <a:t>Customer 2
-</a:t>
-            </a:r>
+              <a:t>Customer 2</a:t>
+            </a:r>
+            <a:endParaRPr lang="en-US" sz="1100" dirty="0"/>
+          </a:p>
+          <a:p>
             <a:pPr algn="ctr" indent="0" marL="0">
               <a:buNone/>
             </a:pPr>
@@ -20121,9 +20125,11 @@
                 <a:ea typeface="Calibri" pitchFamily="34" charset="-122"/>
                 <a:cs typeface="Calibri" pitchFamily="34" charset="-120"/>
               </a:rPr>
-              <a:t>Customer N
-</a:t>
-            </a:r>
+              <a:t>Customer N</a:t>
+            </a:r>
+            <a:endParaRPr lang="en-US" sz="1100" dirty="0"/>
+          </a:p>
+          <a:p>
             <a:pPr algn="ctr" indent="0" marL="0">
               <a:buNone/>
             </a:pPr>

</xml_diff>

<commit_message>
deck: fix PowerPoint repair prompt (negative shape extent on arrows)
The arrow() helper passed negative width/height to PptxGenJS, emitting a negative <a:ext> (e.g. cy=-45720) on slide 3 — invalid per ST_PositiveCoordinate, which made PowerPoint offer to repair the file. arrow() now emits a non-negative bounding box and expresses direction via flipH/flipV. Validated: 0 negative extents, 0 XML parse errors, 0 broken rels across all parts; all 15 slides re-rendered.

Co-authored-by: Copilot <223556219+Copilot@users.noreply.github.com>
</commit_message>
<xml_diff>
--- a/docs/FY27 EMEA EPS - Fabric Apps Motion - Micro Hack.pptx
+++ b/docs/FY27 EMEA EPS - Fabric Apps Motion - Micro Hack.pptx
@@ -11090,9 +11090,9 @@
           <p:nvPr/>
         </p:nvSpPr>
         <p:spPr>
-          <a:xfrm>
-            <a:off x="6995160" y="2468880"/>
-            <a:ext cx="502920" cy="-45720"/>
+          <a:xfrm flipV="1">
+            <a:off x="6995160" y="2423160"/>
+            <a:ext cx="502920" cy="45720"/>
           </a:xfrm>
           <a:prstGeom prst="line">
             <a:avLst/>

</xml_diff>